<commit_message>
all-slides-with-answers.pdf all-slides.pdf code.zip decorators.pdf decorators.pptx dynamic_programming.pdf dynamic_programming.pptx
</commit_message>
<xml_diff>
--- a/ipsa/slides/dynamic_programming.pptx
+++ b/ipsa/slides/dynamic_programming.pptx
@@ -135,283 +135,105 @@
 </p:presentation>
 </file>
 
+<file path=ppt/revisionInfo.xml><?xml version="1.0" encoding="utf-8"?>
+<p1510:revInfo xmlns:a="http://schemas.openxmlformats.org/drawingml/2006/main" xmlns:r="http://schemas.openxmlformats.org/officeDocument/2006/relationships" xmlns:p1510="http://schemas.microsoft.com/office/powerpoint/2015/10/main">
+  <p1510:revLst>
+    <p1510:client id="{F524081E-5DBD-4F84-82FA-7B60D6FA1DED}" v="23" dt="2026-03-18T08:46:59.451"/>
+  </p1510:revLst>
+</p1510:revInfo>
+</file>
+
 <file path=ppt/changesInfos/changesInfo1.xml><?xml version="1.0" encoding="utf-8"?>
 <pc:chgInfo xmlns:a="http://schemas.openxmlformats.org/drawingml/2006/main" xmlns:r="http://schemas.openxmlformats.org/officeDocument/2006/relationships" xmlns:ac="http://schemas.microsoft.com/office/drawing/2013/main/command" xmlns:pc="http://schemas.microsoft.com/office/powerpoint/2013/main/command">
   <pc:docChgLst>
-    <pc:chgData name="Gerth Stølting Brodal" userId="04ef4784-6591-4f86-a140-f5c3b108582a" providerId="ADAL" clId="{EEFC9CB5-B621-4538-9B6B-9E706B2CA24E}"/>
-    <pc:docChg chg="modSld">
-      <pc:chgData name="Gerth Stølting Brodal" userId="04ef4784-6591-4f86-a140-f5c3b108582a" providerId="ADAL" clId="{EEFC9CB5-B621-4538-9B6B-9E706B2CA24E}" dt="2024-03-19T18:48:15.392" v="1" actId="20577"/>
+    <pc:chgData name="Gerth Stølting Brodal" userId="04ef4784-6591-4f86-a140-f5c3b108582a" providerId="ADAL" clId="{73BAC7D6-516A-44B5-B4B0-C7B08CA8B392}"/>
+    <pc:docChg chg="custSel modSld">
+      <pc:chgData name="Gerth Stølting Brodal" userId="04ef4784-6591-4f86-a140-f5c3b108582a" providerId="ADAL" clId="{73BAC7D6-516A-44B5-B4B0-C7B08CA8B392}" dt="2026-03-18T08:47:02.450" v="254" actId="14100"/>
       <pc:docMkLst>
         <pc:docMk/>
       </pc:docMkLst>
-      <pc:sldChg chg="mod modShow">
-        <pc:chgData name="Gerth Stølting Brodal" userId="04ef4784-6591-4f86-a140-f5c3b108582a" providerId="ADAL" clId="{EEFC9CB5-B621-4538-9B6B-9E706B2CA24E}" dt="2024-03-19T18:25:37.158" v="0" actId="729"/>
+      <pc:sldChg chg="modSp mod">
+        <pc:chgData name="Gerth Stølting Brodal" userId="04ef4784-6591-4f86-a140-f5c3b108582a" providerId="ADAL" clId="{73BAC7D6-516A-44B5-B4B0-C7B08CA8B392}" dt="2026-03-18T07:27:39.981" v="23" actId="6549"/>
         <pc:sldMkLst>
           <pc:docMk/>
-          <pc:sldMk cId="1347015518" sldId="762"/>
+          <pc:sldMk cId="2336252860" sldId="713"/>
         </pc:sldMkLst>
+        <pc:spChg chg="mod">
+          <ac:chgData name="Gerth Stølting Brodal" userId="04ef4784-6591-4f86-a140-f5c3b108582a" providerId="ADAL" clId="{73BAC7D6-516A-44B5-B4B0-C7B08CA8B392}" dt="2026-03-18T07:27:39.981" v="23" actId="6549"/>
+          <ac:spMkLst>
+            <pc:docMk/>
+            <pc:sldMk cId="2336252860" sldId="713"/>
+            <ac:spMk id="3" creationId="{00000000-0000-0000-0000-000000000000}"/>
+          </ac:spMkLst>
+        </pc:spChg>
       </pc:sldChg>
-      <pc:sldChg chg="mod modShow">
-        <pc:chgData name="Gerth Stølting Brodal" userId="04ef4784-6591-4f86-a140-f5c3b108582a" providerId="ADAL" clId="{EEFC9CB5-B621-4538-9B6B-9E706B2CA24E}" dt="2024-03-19T18:25:37.158" v="0" actId="729"/>
+      <pc:sldChg chg="modSp mod modNotesTx">
+        <pc:chgData name="Gerth Stølting Brodal" userId="04ef4784-6591-4f86-a140-f5c3b108582a" providerId="ADAL" clId="{73BAC7D6-516A-44B5-B4B0-C7B08CA8B392}" dt="2026-03-18T06:47:26.756" v="21" actId="1582"/>
         <pc:sldMkLst>
           <pc:docMk/>
-          <pc:sldMk cId="1052038409" sldId="763"/>
+          <pc:sldMk cId="1817916657" sldId="760"/>
         </pc:sldMkLst>
+        <pc:spChg chg="mod">
+          <ac:chgData name="Gerth Stølting Brodal" userId="04ef4784-6591-4f86-a140-f5c3b108582a" providerId="ADAL" clId="{73BAC7D6-516A-44B5-B4B0-C7B08CA8B392}" dt="2026-03-18T06:47:26.756" v="21" actId="1582"/>
+          <ac:spMkLst>
+            <pc:docMk/>
+            <pc:sldMk cId="1817916657" sldId="760"/>
+            <ac:spMk id="11" creationId="{00000000-0000-0000-0000-000000000000}"/>
+          </ac:spMkLst>
+        </pc:spChg>
       </pc:sldChg>
-      <pc:sldChg chg="modSp modAnim">
-        <pc:chgData name="Gerth Stølting Brodal" userId="04ef4784-6591-4f86-a140-f5c3b108582a" providerId="ADAL" clId="{EEFC9CB5-B621-4538-9B6B-9E706B2CA24E}" dt="2024-03-19T18:48:15.392" v="1" actId="20577"/>
+      <pc:sldChg chg="modSp mod modNotesTx">
+        <pc:chgData name="Gerth Stølting Brodal" userId="04ef4784-6591-4f86-a140-f5c3b108582a" providerId="ADAL" clId="{73BAC7D6-516A-44B5-B4B0-C7B08CA8B392}" dt="2026-03-18T06:34:24.431" v="4" actId="20577"/>
+        <pc:sldMkLst>
+          <pc:docMk/>
+          <pc:sldMk cId="1651261074" sldId="768"/>
+        </pc:sldMkLst>
+        <pc:spChg chg="mod">
+          <ac:chgData name="Gerth Stølting Brodal" userId="04ef4784-6591-4f86-a140-f5c3b108582a" providerId="ADAL" clId="{73BAC7D6-516A-44B5-B4B0-C7B08CA8B392}" dt="2026-03-18T06:34:24.431" v="4" actId="20577"/>
+          <ac:spMkLst>
+            <pc:docMk/>
+            <pc:sldMk cId="1651261074" sldId="768"/>
+            <ac:spMk id="3" creationId="{00000000-0000-0000-0000-000000000000}"/>
+          </ac:spMkLst>
+        </pc:spChg>
+      </pc:sldChg>
+      <pc:sldChg chg="modSp mod">
+        <pc:chgData name="Gerth Stølting Brodal" userId="04ef4784-6591-4f86-a140-f5c3b108582a" providerId="ADAL" clId="{73BAC7D6-516A-44B5-B4B0-C7B08CA8B392}" dt="2026-03-18T07:40:41.415" v="35" actId="20577"/>
+        <pc:sldMkLst>
+          <pc:docMk/>
+          <pc:sldMk cId="426845446" sldId="776"/>
+        </pc:sldMkLst>
+        <pc:spChg chg="mod">
+          <ac:chgData name="Gerth Stølting Brodal" userId="04ef4784-6591-4f86-a140-f5c3b108582a" providerId="ADAL" clId="{73BAC7D6-516A-44B5-B4B0-C7B08CA8B392}" dt="2026-03-18T07:40:41.415" v="35" actId="20577"/>
+          <ac:spMkLst>
+            <pc:docMk/>
+            <pc:sldMk cId="426845446" sldId="776"/>
+            <ac:spMk id="3" creationId="{00000000-0000-0000-0000-000000000000}"/>
+          </ac:spMkLst>
+        </pc:spChg>
+      </pc:sldChg>
+      <pc:sldChg chg="modSp mod">
+        <pc:chgData name="Gerth Stølting Brodal" userId="04ef4784-6591-4f86-a140-f5c3b108582a" providerId="ADAL" clId="{73BAC7D6-516A-44B5-B4B0-C7B08CA8B392}" dt="2026-03-18T08:47:02.450" v="254" actId="14100"/>
         <pc:sldMkLst>
           <pc:docMk/>
           <pc:sldMk cId="2179044661" sldId="779"/>
         </pc:sldMkLst>
-      </pc:sldChg>
-    </pc:docChg>
-  </pc:docChgLst>
-  <pc:docChgLst>
-    <pc:chgData name="Gerth Stølting Brodal" userId="04ef4784-6591-4f86-a140-f5c3b108582a" providerId="ADAL" clId="{5E934D0D-E0ED-440B-BCC3-3ABCA8CDCAB1}"/>
-    <pc:docChg chg="modSld">
-      <pc:chgData name="Gerth Stølting Brodal" userId="04ef4784-6591-4f86-a140-f5c3b108582a" providerId="ADAL" clId="{5E934D0D-E0ED-440B-BCC3-3ABCA8CDCAB1}" dt="2022-03-27T11:34:02.138" v="1" actId="20577"/>
-      <pc:docMkLst>
-        <pc:docMk/>
-      </pc:docMkLst>
-      <pc:sldChg chg="modSp mod">
-        <pc:chgData name="Gerth Stølting Brodal" userId="04ef4784-6591-4f86-a140-f5c3b108582a" providerId="ADAL" clId="{5E934D0D-E0ED-440B-BCC3-3ABCA8CDCAB1}" dt="2022-03-27T11:34:02.138" v="1" actId="20577"/>
-        <pc:sldMkLst>
-          <pc:docMk/>
-          <pc:sldMk cId="2137239356" sldId="775"/>
-        </pc:sldMkLst>
-      </pc:sldChg>
-    </pc:docChg>
-  </pc:docChgLst>
-  <pc:docChgLst>
-    <pc:chgData name="Gerth Stølting Brodal" userId="04ef4784-6591-4f86-a140-f5c3b108582a" providerId="ADAL" clId="{E6D98D54-2BE6-45FC-8353-A1E0922E1443}"/>
-    <pc:docChg chg="custSel modSld">
-      <pc:chgData name="Gerth Stølting Brodal" userId="04ef4784-6591-4f86-a140-f5c3b108582a" providerId="ADAL" clId="{E6D98D54-2BE6-45FC-8353-A1E0922E1443}" dt="2021-04-16T09:00:18.763" v="196" actId="20577"/>
-      <pc:docMkLst>
-        <pc:docMk/>
-      </pc:docMkLst>
-      <pc:sldChg chg="addSp delSp modSp mod modNotesTx">
-        <pc:chgData name="Gerth Stølting Brodal" userId="04ef4784-6591-4f86-a140-f5c3b108582a" providerId="ADAL" clId="{E6D98D54-2BE6-45FC-8353-A1E0922E1443}" dt="2021-04-16T09:00:18.763" v="196" actId="20577"/>
-        <pc:sldMkLst>
-          <pc:docMk/>
-          <pc:sldMk cId="1651261074" sldId="768"/>
-        </pc:sldMkLst>
-      </pc:sldChg>
-    </pc:docChg>
-  </pc:docChgLst>
-  <pc:docChgLst>
-    <pc:chgData name="Gerth Stølting Brodal" userId="04ef4784-6591-4f86-a140-f5c3b108582a" providerId="ADAL" clId="{231CD4DA-6602-4AAE-A1EC-6809FECBDBA5}"/>
-    <pc:docChg chg="undo custSel modSld">
-      <pc:chgData name="Gerth Stølting Brodal" userId="04ef4784-6591-4f86-a140-f5c3b108582a" providerId="ADAL" clId="{231CD4DA-6602-4AAE-A1EC-6809FECBDBA5}" dt="2024-11-28T00:10:08.200" v="304" actId="20577"/>
-      <pc:docMkLst>
-        <pc:docMk/>
-      </pc:docMkLst>
-      <pc:sldChg chg="addSp modSp mod modAnim modNotesTx">
-        <pc:chgData name="Gerth Stølting Brodal" userId="04ef4784-6591-4f86-a140-f5c3b108582a" providerId="ADAL" clId="{231CD4DA-6602-4AAE-A1EC-6809FECBDBA5}" dt="2024-11-28T00:10:08.200" v="304" actId="20577"/>
-        <pc:sldMkLst>
-          <pc:docMk/>
-          <pc:sldMk cId="1651261074" sldId="768"/>
-        </pc:sldMkLst>
-      </pc:sldChg>
-    </pc:docChg>
-  </pc:docChgLst>
-  <pc:docChgLst>
-    <pc:chgData name="Gerth Stølting Brodal" userId="04ef4784-6591-4f86-a140-f5c3b108582a" providerId="ADAL" clId="{882796F6-D19C-46A6-B13D-50D31961200E}"/>
-    <pc:docChg chg="custSel modSld">
-      <pc:chgData name="Gerth Stølting Brodal" userId="04ef4784-6591-4f86-a140-f5c3b108582a" providerId="ADAL" clId="{882796F6-D19C-46A6-B13D-50D31961200E}" dt="2025-03-12T19:48:12.704" v="30" actId="478"/>
-      <pc:docMkLst>
-        <pc:docMk/>
-      </pc:docMkLst>
-      <pc:sldChg chg="modSp mod">
-        <pc:chgData name="Gerth Stølting Brodal" userId="04ef4784-6591-4f86-a140-f5c3b108582a" providerId="ADAL" clId="{882796F6-D19C-46A6-B13D-50D31961200E}" dt="2025-03-12T19:32:39.195" v="11" actId="20577"/>
-        <pc:sldMkLst>
-          <pc:docMk/>
-          <pc:sldMk cId="1651261074" sldId="768"/>
-        </pc:sldMkLst>
-      </pc:sldChg>
-      <pc:sldChg chg="addSp modSp mod">
-        <pc:chgData name="Gerth Stølting Brodal" userId="04ef4784-6591-4f86-a140-f5c3b108582a" providerId="ADAL" clId="{882796F6-D19C-46A6-B13D-50D31961200E}" dt="2025-03-12T19:38:41.889" v="26" actId="1582"/>
-        <pc:sldMkLst>
-          <pc:docMk/>
-          <pc:sldMk cId="2693492495" sldId="770"/>
-        </pc:sldMkLst>
-      </pc:sldChg>
-      <pc:sldChg chg="addSp delSp modSp mod">
-        <pc:chgData name="Gerth Stølting Brodal" userId="04ef4784-6591-4f86-a140-f5c3b108582a" providerId="ADAL" clId="{882796F6-D19C-46A6-B13D-50D31961200E}" dt="2025-03-12T19:48:12.704" v="30" actId="478"/>
-        <pc:sldMkLst>
-          <pc:docMk/>
-          <pc:sldMk cId="3735983945" sldId="772"/>
-        </pc:sldMkLst>
-      </pc:sldChg>
-    </pc:docChg>
-  </pc:docChgLst>
-  <pc:docChgLst>
-    <pc:chgData name="Gerth Stølting Brodal" userId="04ef4784-6591-4f86-a140-f5c3b108582a" providerId="ADAL" clId="{77F58773-95E0-4B50-9119-D6D5F98CF104}"/>
-    <pc:docChg chg="undo redo custSel modSld">
-      <pc:chgData name="Gerth Stølting Brodal" userId="04ef4784-6591-4f86-a140-f5c3b108582a" providerId="ADAL" clId="{77F58773-95E0-4B50-9119-D6D5F98CF104}" dt="2022-03-23T12:25:47.008" v="292" actId="114"/>
-      <pc:docMkLst>
-        <pc:docMk/>
-      </pc:docMkLst>
-      <pc:sldChg chg="modSp mod">
-        <pc:chgData name="Gerth Stølting Brodal" userId="04ef4784-6591-4f86-a140-f5c3b108582a" providerId="ADAL" clId="{77F58773-95E0-4B50-9119-D6D5F98CF104}" dt="2022-03-22T18:14:32.885" v="11" actId="20577"/>
-        <pc:sldMkLst>
-          <pc:docMk/>
-          <pc:sldMk cId="2166608754" sldId="591"/>
-        </pc:sldMkLst>
-      </pc:sldChg>
-      <pc:sldChg chg="modSp">
-        <pc:chgData name="Gerth Stølting Brodal" userId="04ef4784-6591-4f86-a140-f5c3b108582a" providerId="ADAL" clId="{77F58773-95E0-4B50-9119-D6D5F98CF104}" dt="2022-03-22T18:40:41" v="171" actId="20577"/>
-        <pc:sldMkLst>
-          <pc:docMk/>
-          <pc:sldMk cId="2336252860" sldId="713"/>
-        </pc:sldMkLst>
-      </pc:sldChg>
-      <pc:sldChg chg="modSp mod">
-        <pc:chgData name="Gerth Stølting Brodal" userId="04ef4784-6591-4f86-a140-f5c3b108582a" providerId="ADAL" clId="{77F58773-95E0-4B50-9119-D6D5F98CF104}" dt="2022-03-22T19:59:17.368" v="291" actId="20577"/>
-        <pc:sldMkLst>
-          <pc:docMk/>
-          <pc:sldMk cId="1347015518" sldId="762"/>
-        </pc:sldMkLst>
-      </pc:sldChg>
-      <pc:sldChg chg="modSp mod">
-        <pc:chgData name="Gerth Stølting Brodal" userId="04ef4784-6591-4f86-a140-f5c3b108582a" providerId="ADAL" clId="{77F58773-95E0-4B50-9119-D6D5F98CF104}" dt="2022-03-22T18:17:41.427" v="55" actId="20577"/>
-        <pc:sldMkLst>
-          <pc:docMk/>
-          <pc:sldMk cId="406105154" sldId="765"/>
-        </pc:sldMkLst>
-      </pc:sldChg>
-      <pc:sldChg chg="modSp mod">
-        <pc:chgData name="Gerth Stølting Brodal" userId="04ef4784-6591-4f86-a140-f5c3b108582a" providerId="ADAL" clId="{77F58773-95E0-4B50-9119-D6D5F98CF104}" dt="2022-03-22T18:23:43.395" v="68" actId="20577"/>
-        <pc:sldMkLst>
-          <pc:docMk/>
-          <pc:sldMk cId="3429451799" sldId="766"/>
-        </pc:sldMkLst>
-      </pc:sldChg>
-      <pc:sldChg chg="modSp mod">
-        <pc:chgData name="Gerth Stølting Brodal" userId="04ef4784-6591-4f86-a140-f5c3b108582a" providerId="ADAL" clId="{77F58773-95E0-4B50-9119-D6D5F98CF104}" dt="2022-03-22T18:28:06.672" v="167" actId="1076"/>
-        <pc:sldMkLst>
-          <pc:docMk/>
-          <pc:sldMk cId="1651261074" sldId="768"/>
-        </pc:sldMkLst>
-      </pc:sldChg>
-      <pc:sldChg chg="modNotesTx">
-        <pc:chgData name="Gerth Stølting Brodal" userId="04ef4784-6591-4f86-a140-f5c3b108582a" providerId="ADAL" clId="{77F58773-95E0-4B50-9119-D6D5F98CF104}" dt="2022-03-22T19:45:34.047" v="277" actId="20577"/>
-        <pc:sldMkLst>
-          <pc:docMk/>
-          <pc:sldMk cId="27118936" sldId="769"/>
-        </pc:sldMkLst>
-      </pc:sldChg>
-      <pc:sldChg chg="modSp mod">
-        <pc:chgData name="Gerth Stølting Brodal" userId="04ef4784-6591-4f86-a140-f5c3b108582a" providerId="ADAL" clId="{77F58773-95E0-4B50-9119-D6D5F98CF104}" dt="2022-03-22T18:45:06.745" v="179" actId="1076"/>
-        <pc:sldMkLst>
-          <pc:docMk/>
-          <pc:sldMk cId="2693492495" sldId="770"/>
-        </pc:sldMkLst>
-      </pc:sldChg>
-      <pc:sldChg chg="modSp mod">
-        <pc:chgData name="Gerth Stølting Brodal" userId="04ef4784-6591-4f86-a140-f5c3b108582a" providerId="ADAL" clId="{77F58773-95E0-4B50-9119-D6D5F98CF104}" dt="2022-03-22T18:55:45.676" v="188" actId="14734"/>
-        <pc:sldMkLst>
-          <pc:docMk/>
-          <pc:sldMk cId="3735983945" sldId="772"/>
-        </pc:sldMkLst>
-      </pc:sldChg>
-      <pc:sldChg chg="modSp mod">
-        <pc:chgData name="Gerth Stølting Brodal" userId="04ef4784-6591-4f86-a140-f5c3b108582a" providerId="ADAL" clId="{77F58773-95E0-4B50-9119-D6D5F98CF104}" dt="2022-03-23T12:25:47.008" v="292" actId="114"/>
-        <pc:sldMkLst>
-          <pc:docMk/>
-          <pc:sldMk cId="949823138" sldId="778"/>
-        </pc:sldMkLst>
-      </pc:sldChg>
-    </pc:docChg>
-  </pc:docChgLst>
-  <pc:docChgLst>
-    <pc:chgData name="Gerth Stølting Brodal" userId="04ef4784-6591-4f86-a140-f5c3b108582a" providerId="ADAL" clId="{27124F44-A0F7-408A-AA2B-2C5136C1DC06}"/>
-    <pc:docChg chg="modSld">
-      <pc:chgData name="Gerth Stølting Brodal" userId="04ef4784-6591-4f86-a140-f5c3b108582a" providerId="ADAL" clId="{27124F44-A0F7-408A-AA2B-2C5136C1DC06}" dt="2025-10-27T18:34:06.831" v="5" actId="962"/>
-      <pc:docMkLst>
-        <pc:docMk/>
-      </pc:docMkLst>
-      <pc:sldChg chg="modSp mod">
-        <pc:chgData name="Gerth Stølting Brodal" userId="04ef4784-6591-4f86-a140-f5c3b108582a" providerId="ADAL" clId="{27124F44-A0F7-408A-AA2B-2C5136C1DC06}" dt="2025-10-27T18:33:55.103" v="1" actId="962"/>
-        <pc:sldMkLst>
-          <pc:docMk/>
-          <pc:sldMk cId="406105154" sldId="765"/>
-        </pc:sldMkLst>
         <pc:spChg chg="mod">
-          <ac:chgData name="Gerth Stølting Brodal" userId="04ef4784-6591-4f86-a140-f5c3b108582a" providerId="ADAL" clId="{27124F44-A0F7-408A-AA2B-2C5136C1DC06}" dt="2025-10-27T18:33:55.103" v="1" actId="962"/>
+          <ac:chgData name="Gerth Stølting Brodal" userId="04ef4784-6591-4f86-a140-f5c3b108582a" providerId="ADAL" clId="{73BAC7D6-516A-44B5-B4B0-C7B08CA8B392}" dt="2026-03-18T08:47:02.450" v="254" actId="14100"/>
           <ac:spMkLst>
             <pc:docMk/>
-            <pc:sldMk cId="406105154" sldId="765"/>
+            <pc:sldMk cId="2179044661" sldId="779"/>
+            <ac:spMk id="3" creationId="{00000000-0000-0000-0000-000000000000}"/>
+          </ac:spMkLst>
+        </pc:spChg>
+        <pc:spChg chg="mod">
+          <ac:chgData name="Gerth Stølting Brodal" userId="04ef4784-6591-4f86-a140-f5c3b108582a" providerId="ADAL" clId="{73BAC7D6-516A-44B5-B4B0-C7B08CA8B392}" dt="2026-03-18T08:46:52.690" v="251" actId="20577"/>
+          <ac:spMkLst>
+            <pc:docMk/>
+            <pc:sldMk cId="2179044661" sldId="779"/>
             <ac:spMk id="4" creationId="{00000000-0000-0000-0000-000000000000}"/>
           </ac:spMkLst>
         </pc:spChg>
-      </pc:sldChg>
-      <pc:sldChg chg="modSp mod">
-        <pc:chgData name="Gerth Stølting Brodal" userId="04ef4784-6591-4f86-a140-f5c3b108582a" providerId="ADAL" clId="{27124F44-A0F7-408A-AA2B-2C5136C1DC06}" dt="2025-10-27T18:34:06.831" v="5" actId="962"/>
-        <pc:sldMkLst>
-          <pc:docMk/>
-          <pc:sldMk cId="3142937555" sldId="771"/>
-        </pc:sldMkLst>
-        <pc:spChg chg="mod">
-          <ac:chgData name="Gerth Stølting Brodal" userId="04ef4784-6591-4f86-a140-f5c3b108582a" providerId="ADAL" clId="{27124F44-A0F7-408A-AA2B-2C5136C1DC06}" dt="2025-10-27T18:34:04.271" v="3" actId="962"/>
-          <ac:spMkLst>
-            <pc:docMk/>
-            <pc:sldMk cId="3142937555" sldId="771"/>
-            <ac:spMk id="5" creationId="{00000000-0000-0000-0000-000000000000}"/>
-          </ac:spMkLst>
-        </pc:spChg>
-        <pc:spChg chg="mod">
-          <ac:chgData name="Gerth Stølting Brodal" userId="04ef4784-6591-4f86-a140-f5c3b108582a" providerId="ADAL" clId="{27124F44-A0F7-408A-AA2B-2C5136C1DC06}" dt="2025-10-27T18:34:06.831" v="5" actId="962"/>
-          <ac:spMkLst>
-            <pc:docMk/>
-            <pc:sldMk cId="3142937555" sldId="771"/>
-            <ac:spMk id="6" creationId="{00000000-0000-0000-0000-000000000000}"/>
-          </ac:spMkLst>
-        </pc:spChg>
-      </pc:sldChg>
-    </pc:docChg>
-  </pc:docChgLst>
-  <pc:docChgLst>
-    <pc:chgData name="Gerth Stølting Brodal" userId="04ef4784-6591-4f86-a140-f5c3b108582a" providerId="ADAL" clId="{83752B0F-B9FA-4319-9D65-0FA02808F4AB}"/>
-    <pc:docChg chg="custSel modSld">
-      <pc:chgData name="Gerth Stølting Brodal" userId="04ef4784-6591-4f86-a140-f5c3b108582a" providerId="ADAL" clId="{83752B0F-B9FA-4319-9D65-0FA02808F4AB}" dt="2023-03-22T12:37:22.499" v="244" actId="20577"/>
-      <pc:docMkLst>
-        <pc:docMk/>
-      </pc:docMkLst>
-      <pc:sldChg chg="modSp mod">
-        <pc:chgData name="Gerth Stølting Brodal" userId="04ef4784-6591-4f86-a140-f5c3b108582a" providerId="ADAL" clId="{83752B0F-B9FA-4319-9D65-0FA02808F4AB}" dt="2023-03-22T12:05:29.205" v="48" actId="1076"/>
-        <pc:sldMkLst>
-          <pc:docMk/>
-          <pc:sldMk cId="147360573" sldId="468"/>
-        </pc:sldMkLst>
-      </pc:sldChg>
-      <pc:sldChg chg="modSp mod modNotesTx">
-        <pc:chgData name="Gerth Stølting Brodal" userId="04ef4784-6591-4f86-a140-f5c3b108582a" providerId="ADAL" clId="{83752B0F-B9FA-4319-9D65-0FA02808F4AB}" dt="2023-03-22T12:37:05.239" v="239" actId="20577"/>
-        <pc:sldMkLst>
-          <pc:docMk/>
-          <pc:sldMk cId="2336252860" sldId="713"/>
-        </pc:sldMkLst>
-      </pc:sldChg>
-      <pc:sldChg chg="modSp mod">
-        <pc:chgData name="Gerth Stølting Brodal" userId="04ef4784-6591-4f86-a140-f5c3b108582a" providerId="ADAL" clId="{83752B0F-B9FA-4319-9D65-0FA02808F4AB}" dt="2023-03-22T12:08:31.205" v="52" actId="1076"/>
-        <pc:sldMkLst>
-          <pc:docMk/>
-          <pc:sldMk cId="2565521373" sldId="761"/>
-        </pc:sldMkLst>
-      </pc:sldChg>
-      <pc:sldChg chg="modNotesTx">
-        <pc:chgData name="Gerth Stølting Brodal" userId="04ef4784-6591-4f86-a140-f5c3b108582a" providerId="ADAL" clId="{83752B0F-B9FA-4319-9D65-0FA02808F4AB}" dt="2023-03-22T12:27:48.596" v="190" actId="20577"/>
-        <pc:sldMkLst>
-          <pc:docMk/>
-          <pc:sldMk cId="3142937555" sldId="771"/>
-        </pc:sldMkLst>
-      </pc:sldChg>
-      <pc:sldChg chg="modSp mod">
-        <pc:chgData name="Gerth Stølting Brodal" userId="04ef4784-6591-4f86-a140-f5c3b108582a" providerId="ADAL" clId="{83752B0F-B9FA-4319-9D65-0FA02808F4AB}" dt="2023-03-22T12:37:22.499" v="244" actId="20577"/>
-        <pc:sldMkLst>
-          <pc:docMk/>
-          <pc:sldMk cId="2489620528" sldId="773"/>
-        </pc:sldMkLst>
       </pc:sldChg>
     </pc:docChg>
   </pc:docChgLst>
@@ -500,7 +322,7 @@
           <a:p>
             <a:fld id="{FB1A172F-81D4-4DC4-9113-1DBD56EC3646}" type="datetimeFigureOut">
               <a:rPr lang="en-US" smtClean="0"/>
-              <a:t>10/27/2025</a:t>
+              <a:t>3/18/2026</a:t>
             </a:fld>
             <a:endParaRPr lang="en-US"/>
           </a:p>
@@ -940,7 +762,7 @@
             </a:r>
             <a:r>
               <a:rPr lang="da-DK" baseline="0" dirty="0"/>
-              <a:t> of the </a:t>
+              <a:t> (red pairs) of the </a:t>
             </a:r>
             <a:r>
               <a:rPr lang="da-DK" baseline="0" dirty="0" err="1"/>
@@ -956,15 +778,7 @@
             </a:r>
             <a:r>
               <a:rPr lang="da-DK" baseline="0" dirty="0"/>
-              <a:t> </a:t>
-            </a:r>
-            <a:r>
-              <a:rPr lang="da-DK" baseline="0" dirty="0" err="1"/>
-              <a:t>returns</a:t>
-            </a:r>
-            <a:r>
-              <a:rPr lang="da-DK" baseline="0" dirty="0"/>
-              <a:t> 1)</a:t>
+              <a:t> returns 1)</a:t>
             </a:r>
             <a:endParaRPr lang="da-DK" dirty="0"/>
           </a:p>
@@ -1547,7 +1361,7 @@
             </a:r>
             <a:r>
               <a:rPr lang="en-US" dirty="0"/>
-              <a:t> decorators also inhere in the docstrings (.__doc__), such that help and </a:t>
+              <a:t> decorators also inhere the docstrings (.__doc__), such that help and </a:t>
             </a:r>
             <a:r>
               <a:rPr lang="en-US" dirty="0" err="1"/>
@@ -1579,12 +1393,8 @@
               <a:t>recursionlimit</a:t>
             </a:r>
             <a:r>
-              <a:rPr lang="en-US"/>
-              <a:t>: https</a:t>
-            </a:r>
-            <a:r>
               <a:rPr lang="en-US" dirty="0"/>
-              <a:t>://github.com/python/cpython/issues/112215</a:t>
+              <a:t>: https://github.com/python/cpython/issues/112215</a:t>
             </a:r>
           </a:p>
         </p:txBody>
@@ -2206,7 +2016,7 @@
           <a:p>
             <a:fld id="{0560A9CD-0304-4E0B-9E82-E7E0115DE05B}" type="datetimeFigureOut">
               <a:rPr lang="en-US" smtClean="0"/>
-              <a:t>10/27/2025</a:t>
+              <a:t>3/18/2026</a:t>
             </a:fld>
             <a:endParaRPr lang="en-US"/>
           </a:p>
@@ -2374,7 +2184,7 @@
           <a:p>
             <a:fld id="{0560A9CD-0304-4E0B-9E82-E7E0115DE05B}" type="datetimeFigureOut">
               <a:rPr lang="en-US" smtClean="0"/>
-              <a:t>10/27/2025</a:t>
+              <a:t>3/18/2026</a:t>
             </a:fld>
             <a:endParaRPr lang="en-US"/>
           </a:p>
@@ -2552,7 +2362,7 @@
           <a:p>
             <a:fld id="{0560A9CD-0304-4E0B-9E82-E7E0115DE05B}" type="datetimeFigureOut">
               <a:rPr lang="en-US" smtClean="0"/>
-              <a:t>10/27/2025</a:t>
+              <a:t>3/18/2026</a:t>
             </a:fld>
             <a:endParaRPr lang="en-US"/>
           </a:p>
@@ -2735,7 +2545,7 @@
           <a:p>
             <a:fld id="{0560A9CD-0304-4E0B-9E82-E7E0115DE05B}" type="datetimeFigureOut">
               <a:rPr lang="en-US" smtClean="0"/>
-              <a:t>10/27/2025</a:t>
+              <a:t>3/18/2026</a:t>
             </a:fld>
             <a:endParaRPr lang="en-US"/>
           </a:p>
@@ -2980,7 +2790,7 @@
           <a:p>
             <a:fld id="{0560A9CD-0304-4E0B-9E82-E7E0115DE05B}" type="datetimeFigureOut">
               <a:rPr lang="en-US" smtClean="0"/>
-              <a:t>10/27/2025</a:t>
+              <a:t>3/18/2026</a:t>
             </a:fld>
             <a:endParaRPr lang="en-US"/>
           </a:p>
@@ -3209,7 +3019,7 @@
           <a:p>
             <a:fld id="{0560A9CD-0304-4E0B-9E82-E7E0115DE05B}" type="datetimeFigureOut">
               <a:rPr lang="en-US" smtClean="0"/>
-              <a:t>10/27/2025</a:t>
+              <a:t>3/18/2026</a:t>
             </a:fld>
             <a:endParaRPr lang="en-US"/>
           </a:p>
@@ -3573,7 +3383,7 @@
           <a:p>
             <a:fld id="{0560A9CD-0304-4E0B-9E82-E7E0115DE05B}" type="datetimeFigureOut">
               <a:rPr lang="en-US" smtClean="0"/>
-              <a:t>10/27/2025</a:t>
+              <a:t>3/18/2026</a:t>
             </a:fld>
             <a:endParaRPr lang="en-US"/>
           </a:p>
@@ -3690,7 +3500,7 @@
           <a:p>
             <a:fld id="{0560A9CD-0304-4E0B-9E82-E7E0115DE05B}" type="datetimeFigureOut">
               <a:rPr lang="en-US" smtClean="0"/>
-              <a:t>10/27/2025</a:t>
+              <a:t>3/18/2026</a:t>
             </a:fld>
             <a:endParaRPr lang="en-US"/>
           </a:p>
@@ -3785,7 +3595,7 @@
           <a:p>
             <a:fld id="{0560A9CD-0304-4E0B-9E82-E7E0115DE05B}" type="datetimeFigureOut">
               <a:rPr lang="en-US" smtClean="0"/>
-              <a:t>10/27/2025</a:t>
+              <a:t>3/18/2026</a:t>
             </a:fld>
             <a:endParaRPr lang="en-US"/>
           </a:p>
@@ -4060,7 +3870,7 @@
           <a:p>
             <a:fld id="{0560A9CD-0304-4E0B-9E82-E7E0115DE05B}" type="datetimeFigureOut">
               <a:rPr lang="en-US" smtClean="0"/>
-              <a:t>10/27/2025</a:t>
+              <a:t>3/18/2026</a:t>
             </a:fld>
             <a:endParaRPr lang="en-US"/>
           </a:p>
@@ -4312,7 +4122,7 @@
           <a:p>
             <a:fld id="{0560A9CD-0304-4E0B-9E82-E7E0115DE05B}" type="datetimeFigureOut">
               <a:rPr lang="en-US" smtClean="0"/>
-              <a:t>10/27/2025</a:t>
+              <a:t>3/18/2026</a:t>
             </a:fld>
             <a:endParaRPr lang="en-US"/>
           </a:p>
@@ -4523,7 +4333,7 @@
           <a:p>
             <a:fld id="{0560A9CD-0304-4E0B-9E82-E7E0115DE05B}" type="datetimeFigureOut">
               <a:rPr lang="en-US" smtClean="0"/>
-              <a:t>10/27/2025</a:t>
+              <a:t>3/18/2026</a:t>
             </a:fld>
             <a:endParaRPr lang="en-US"/>
           </a:p>
@@ -16771,11 +16581,49 @@
             <a:pPr lvl="1"/>
             <a:r>
               <a:rPr lang="da-DK" dirty="0"/>
-              <a:t>decorate with a @</a:t>
+              <a:t>decorate with a @memoize or @cache </a:t>
             </a:r>
             <a:r>
               <a:rPr lang="da-DK" dirty="0" err="1"/>
-              <a:t>memoize</a:t>
+              <a:t>decorator</a:t>
+            </a:r>
+            <a:endParaRPr lang="da-DK" dirty="0"/>
+          </a:p>
+          <a:p>
+            <a:r>
+              <a:rPr lang="da-DK" b="1" dirty="0"/>
+              <a:t>Solution 2: </a:t>
+            </a:r>
+            <a:r>
+              <a:rPr lang="da-DK" b="1" dirty="0" err="1"/>
+              <a:t>Systematic</a:t>
+            </a:r>
+            <a:r>
+              <a:rPr lang="da-DK" b="1" dirty="0"/>
+              <a:t> </a:t>
+            </a:r>
+            <a:r>
+              <a:rPr lang="da-DK" b="1" dirty="0" err="1"/>
+              <a:t>table</a:t>
+            </a:r>
+            <a:r>
+              <a:rPr lang="da-DK" b="1" dirty="0"/>
+              <a:t> </a:t>
+            </a:r>
+            <a:r>
+              <a:rPr lang="da-DK" b="1" dirty="0" err="1"/>
+              <a:t>fill</a:t>
+            </a:r>
+            <a:r>
+              <a:rPr lang="da-DK" b="1" dirty="0"/>
+              <a:t> out</a:t>
+            </a:r>
+          </a:p>
+          <a:p>
+            <a:pPr lvl="1"/>
+            <a:r>
+              <a:rPr lang="da-DK" dirty="0" err="1"/>
+              <a:t>can</a:t>
             </a:r>
             <a:r>
               <a:rPr lang="da-DK" dirty="0"/>
@@ -16783,39 +16631,57 @@
             </a:r>
             <a:r>
               <a:rPr lang="da-DK" dirty="0" err="1"/>
-              <a:t>decorator</a:t>
+              <a:t>need</a:t>
+            </a:r>
+            <a:r>
+              <a:rPr lang="da-DK" dirty="0"/>
+              <a:t> to </a:t>
+            </a:r>
+            <a:r>
+              <a:rPr lang="da-DK" dirty="0" err="1"/>
+              <a:t>compute</a:t>
+            </a:r>
+            <a:r>
+              <a:rPr lang="da-DK" dirty="0"/>
+              <a:t> more </a:t>
+            </a:r>
+            <a:r>
+              <a:rPr lang="da-DK" dirty="0" err="1"/>
+              <a:t>values</a:t>
+            </a:r>
+            <a:r>
+              <a:rPr lang="da-DK" dirty="0"/>
+              <a:t> </a:t>
+            </a:r>
+            <a:r>
+              <a:rPr lang="da-DK" dirty="0" err="1"/>
+              <a:t>than</a:t>
+            </a:r>
+            <a:r>
+              <a:rPr lang="da-DK" dirty="0"/>
+              <a:t> </a:t>
+            </a:r>
+            <a:r>
+              <a:rPr lang="da-DK" dirty="0" err="1"/>
+              <a:t>when</a:t>
+            </a:r>
+            <a:r>
+              <a:rPr lang="da-DK" dirty="0"/>
+              <a:t> </a:t>
+            </a:r>
+            <a:r>
+              <a:rPr lang="da-DK" dirty="0" err="1"/>
+              <a:t>using</a:t>
+            </a:r>
+            <a:r>
+              <a:rPr lang="da-DK" dirty="0"/>
+              <a:t> </a:t>
+            </a:r>
+            <a:r>
+              <a:rPr lang="da-DK" dirty="0" err="1"/>
+              <a:t>memoization</a:t>
             </a:r>
             <a:endParaRPr lang="da-DK" dirty="0"/>
-          </a:p>
-          <a:p>
-            <a:r>
-              <a:rPr lang="da-DK" b="1" dirty="0"/>
-              <a:t>Solution 2: </a:t>
-            </a:r>
-            <a:r>
-              <a:rPr lang="da-DK" b="1" dirty="0" err="1"/>
-              <a:t>Systematic</a:t>
-            </a:r>
-            <a:r>
-              <a:rPr lang="da-DK" b="1" dirty="0"/>
-              <a:t> </a:t>
-            </a:r>
-            <a:r>
-              <a:rPr lang="da-DK" b="1" dirty="0" err="1"/>
-              <a:t>table</a:t>
-            </a:r>
-            <a:r>
-              <a:rPr lang="da-DK" b="1" dirty="0"/>
-              <a:t> </a:t>
-            </a:r>
-            <a:r>
-              <a:rPr lang="da-DK" b="1" dirty="0" err="1"/>
-              <a:t>fill</a:t>
-            </a:r>
-            <a:r>
-              <a:rPr lang="da-DK" b="1" dirty="0"/>
-              <a:t> out</a:t>
-            </a:r>
           </a:p>
           <a:p>
             <a:pPr lvl="1"/>
@@ -16825,70 +16691,6 @@
             </a:r>
             <a:r>
               <a:rPr lang="da-DK" dirty="0"/>
-              <a:t> </a:t>
-            </a:r>
-            <a:r>
-              <a:rPr lang="da-DK" dirty="0" err="1"/>
-              <a:t>need</a:t>
-            </a:r>
-            <a:r>
-              <a:rPr lang="da-DK" dirty="0"/>
-              <a:t> to </a:t>
-            </a:r>
-            <a:r>
-              <a:rPr lang="da-DK" dirty="0" err="1"/>
-              <a:t>compute</a:t>
-            </a:r>
-            <a:r>
-              <a:rPr lang="da-DK" dirty="0"/>
-              <a:t> more </a:t>
-            </a:r>
-            <a:r>
-              <a:rPr lang="da-DK" dirty="0" err="1"/>
-              <a:t>values</a:t>
-            </a:r>
-            <a:r>
-              <a:rPr lang="da-DK" dirty="0"/>
-              <a:t> </a:t>
-            </a:r>
-            <a:r>
-              <a:rPr lang="da-DK" dirty="0" err="1"/>
-              <a:t>than</a:t>
-            </a:r>
-            <a:r>
-              <a:rPr lang="da-DK" dirty="0"/>
-              <a:t> </a:t>
-            </a:r>
-            <a:r>
-              <a:rPr lang="da-DK" dirty="0" err="1"/>
-              <a:t>when</a:t>
-            </a:r>
-            <a:r>
-              <a:rPr lang="da-DK" dirty="0"/>
-              <a:t> </a:t>
-            </a:r>
-            <a:r>
-              <a:rPr lang="da-DK" dirty="0" err="1"/>
-              <a:t>using</a:t>
-            </a:r>
-            <a:r>
-              <a:rPr lang="da-DK" dirty="0"/>
-              <a:t> </a:t>
-            </a:r>
-            <a:r>
-              <a:rPr lang="da-DK" dirty="0" err="1"/>
-              <a:t>memoization</a:t>
-            </a:r>
-            <a:endParaRPr lang="da-DK" dirty="0"/>
-          </a:p>
-          <a:p>
-            <a:pPr lvl="1"/>
-            <a:r>
-              <a:rPr lang="da-DK" dirty="0" err="1"/>
-              <a:t>can</a:t>
-            </a:r>
-            <a:r>
-              <a:rPr lang="da-DK" dirty="0"/>
               <a:t> discard </a:t>
             </a:r>
             <a:r>
@@ -16896,7 +16698,7 @@
               <a:t>results</a:t>
             </a:r>
             <a:r>
-              <a:rPr lang="da-DK"/>
+              <a:rPr lang="da-DK" dirty="0"/>
               <a:t> not </a:t>
             </a:r>
             <a:r>
@@ -17008,7 +16810,7 @@
         <p:spPr>
           <a:xfrm>
             <a:off x="838200" y="1825625"/>
-            <a:ext cx="9413240" cy="4351338"/>
+            <a:ext cx="9413240" cy="3959158"/>
           </a:xfrm>
         </p:spPr>
         <p:txBody>
@@ -17020,7 +16822,7 @@
             </a:pPr>
             <a:r>
               <a:rPr lang="en-US" dirty="0"/>
-              <a:t>If you like to practice your coding skills, there are many online “judges” with numerous exercises and where you can upload and test your solutions.</a:t>
+              <a:t>If you like to practice your coding skills, there are many online “judges” with numerous exercises and where you can upload and test your solutions. Examples:</a:t>
             </a:r>
           </a:p>
           <a:p>
@@ -17061,11 +16863,8 @@
               <a:rPr lang="en-US" dirty="0" err="1">
                 <a:hlinkClick r:id="rId5"/>
               </a:rPr>
-              <a:t>Topcoder</a:t>
-            </a:r>
-            <a:endParaRPr lang="en-US" dirty="0"/>
-          </a:p>
-          <a:p>
+              <a:t>LeetCode</a:t>
+            </a:r>
             <a:endParaRPr lang="en-US" dirty="0"/>
           </a:p>
         </p:txBody>
@@ -17078,8 +16877,8 @@
         </p:nvSpPr>
         <p:spPr>
           <a:xfrm>
-            <a:off x="9400852" y="6383774"/>
-            <a:ext cx="2672526" cy="369332"/>
+            <a:off x="8703058" y="6075764"/>
+            <a:ext cx="3361819" cy="646331"/>
           </a:xfrm>
           <a:prstGeom prst="rect">
             <a:avLst/>
@@ -17091,27 +16890,33 @@
           </a:bodyPr>
           <a:lstStyle/>
           <a:p>
+            <a:pPr algn="r"/>
             <a:r>
               <a:rPr lang="en-US" dirty="0"/>
-              <a:t>See </a:t>
+              <a:t>Google ”</a:t>
             </a:r>
             <a:r>
               <a:rPr lang="en-US" dirty="0">
                 <a:hlinkClick r:id="rId6"/>
               </a:rPr>
-              <a:t>cs.au.dk/~</a:t>
-            </a:r>
-            <a:r>
-              <a:rPr lang="en-US" dirty="0" err="1">
-                <a:hlinkClick r:id="rId6"/>
+              <a:t>best online code judges</a:t>
+            </a:r>
+            <a:r>
+              <a:rPr lang="en-US" dirty="0"/>
+              <a:t>” </a:t>
+            </a:r>
+            <a:br>
+              <a:rPr lang="en-US" dirty="0"/>
+            </a:br>
+            <a:r>
+              <a:rPr lang="en-US" dirty="0"/>
+              <a:t>See also </a:t>
+            </a:r>
+            <a:r>
+              <a:rPr lang="en-US" dirty="0">
+                <a:hlinkClick r:id="rId7"/>
               </a:rPr>
-              <a:t>gerth</a:t>
-            </a:r>
-            <a:r>
-              <a:rPr lang="en-US" dirty="0">
-                <a:hlinkClick r:id="rId6"/>
-              </a:rPr>
-              <a:t>/code/</a:t>
+              <a:t>cs.au.dk/~gerth/code/</a:t>
             </a:r>
             <a:endParaRPr lang="en-US" dirty="0"/>
           </a:p>
@@ -19512,7 +19317,7 @@
               <a:gd name="adj2" fmla="val 5224758"/>
             </a:avLst>
           </a:prstGeom>
-          <a:ln>
+          <a:ln w="28575">
             <a:solidFill>
               <a:schemeClr val="accent1">
                 <a:lumMod val="50000"/>
@@ -29926,7 +29731,7 @@
             </a:r>
             <a:r>
               <a:rPr lang="da-DK" sz="2000" dirty="0"/>
-              <a:t>. with Python 3.13 on Windows)</a:t>
+              <a:t>. with Python 3.14 on Windows)</a:t>
             </a:r>
           </a:p>
         </p:txBody>
@@ -30430,7 +30235,7 @@
             </a:r>
             <a:r>
               <a:rPr lang="da-DK" sz="2400" dirty="0"/>
-              <a:t> 13.4)  </a:t>
+              <a:t> 13.5)  </a:t>
             </a:r>
             <a:r>
               <a:rPr lang="da-DK" sz="2400" dirty="0" err="1"/>

</xml_diff>

<commit_message>
all-slides-with-answers.pdf all-slides.pdf code.zip dynamic_programming.pdf dynamic_programming.pptx gui.pdf gui.pptx java.pdf java.pptx
</commit_message>
<xml_diff>
--- a/ipsa/slides/dynamic_programming.pptx
+++ b/ipsa/slides/dynamic_programming.pptx
@@ -147,8 +147,8 @@
 <pc:chgInfo xmlns:a="http://schemas.openxmlformats.org/drawingml/2006/main" xmlns:r="http://schemas.openxmlformats.org/officeDocument/2006/relationships" xmlns:ac="http://schemas.microsoft.com/office/drawing/2013/main/command" xmlns:pc="http://schemas.microsoft.com/office/powerpoint/2013/main/command">
   <pc:docChgLst>
     <pc:chgData name="Gerth Stølting Brodal" userId="04ef4784-6591-4f86-a140-f5c3b108582a" providerId="ADAL" clId="{73BAC7D6-516A-44B5-B4B0-C7B08CA8B392}"/>
-    <pc:docChg chg="custSel modSld">
-      <pc:chgData name="Gerth Stølting Brodal" userId="04ef4784-6591-4f86-a140-f5c3b108582a" providerId="ADAL" clId="{73BAC7D6-516A-44B5-B4B0-C7B08CA8B392}" dt="2026-03-18T08:47:02.450" v="254" actId="14100"/>
+    <pc:docChg chg="undo custSel modSld">
+      <pc:chgData name="Gerth Stølting Brodal" userId="04ef4784-6591-4f86-a140-f5c3b108582a" providerId="ADAL" clId="{73BAC7D6-516A-44B5-B4B0-C7B08CA8B392}" dt="2026-03-18T13:01:11.789" v="268" actId="20577"/>
       <pc:docMkLst>
         <pc:docMk/>
       </pc:docMkLst>
@@ -196,6 +196,21 @@
             <ac:spMk id="3" creationId="{00000000-0000-0000-0000-000000000000}"/>
           </ac:spMkLst>
         </pc:spChg>
+      </pc:sldChg>
+      <pc:sldChg chg="modSp mod">
+        <pc:chgData name="Gerth Stølting Brodal" userId="04ef4784-6591-4f86-a140-f5c3b108582a" providerId="ADAL" clId="{73BAC7D6-516A-44B5-B4B0-C7B08CA8B392}" dt="2026-03-18T13:01:11.789" v="268" actId="20577"/>
+        <pc:sldMkLst>
+          <pc:docMk/>
+          <pc:sldMk cId="3735983945" sldId="772"/>
+        </pc:sldMkLst>
+        <pc:graphicFrameChg chg="mod modGraphic">
+          <ac:chgData name="Gerth Stølting Brodal" userId="04ef4784-6591-4f86-a140-f5c3b108582a" providerId="ADAL" clId="{73BAC7D6-516A-44B5-B4B0-C7B08CA8B392}" dt="2026-03-18T13:01:11.789" v="268" actId="20577"/>
+          <ac:graphicFrameMkLst>
+            <pc:docMk/>
+            <pc:sldMk cId="3735983945" sldId="772"/>
+            <ac:graphicFrameMk id="5" creationId="{00000000-0000-0000-0000-000000000000}"/>
+          </ac:graphicFrameMkLst>
+        </pc:graphicFrameChg>
       </pc:sldChg>
       <pc:sldChg chg="modSp mod">
         <pc:chgData name="Gerth Stølting Brodal" userId="04ef4784-6591-4f86-a140-f5c3b108582a" providerId="ADAL" clId="{73BAC7D6-516A-44B5-B4B0-C7B08CA8B392}" dt="2026-03-18T07:40:41.415" v="35" actId="20577"/>
@@ -7685,7 +7700,7 @@
           <p:nvPr>
             <p:extLst>
               <p:ext uri="{D42A27DB-BD31-4B8C-83A1-F6EECF244321}">
-                <p14:modId xmlns:p14="http://schemas.microsoft.com/office/powerpoint/2010/main" val="2730005600"/>
+                <p14:modId xmlns:p14="http://schemas.microsoft.com/office/powerpoint/2010/main" val="1226930326"/>
               </p:ext>
             </p:extLst>
           </p:nvPr>
@@ -8077,7 +8092,7 @@
                           <a:latin typeface="Courier New" panose="02070309020205020404" pitchFamily="49" charset="0"/>
                           <a:cs typeface="Courier New" panose="02070309020205020404" pitchFamily="49" charset="0"/>
                         </a:rPr>
-                        <a:t>        if solution != None:</a:t>
+                        <a:t>        if solution is not None:</a:t>
                       </a:r>
                     </a:p>
                     <a:p>
@@ -8148,7 +8163,27 @@
                           <a:latin typeface="Courier New" panose="02070309020205020404" pitchFamily="49" charset="0"/>
                           <a:cs typeface="Courier New" panose="02070309020205020404" pitchFamily="49" charset="0"/>
                         </a:rPr>
-                        <a:t>        if solution != None:</a:t>
+                        <a:t>        if </a:t>
+                      </a:r>
+                      <a:r>
+                        <a:rPr lang="en-US" sz="1800" b="1">
+                          <a:solidFill>
+                            <a:schemeClr val="tx1"/>
+                          </a:solidFill>
+                          <a:latin typeface="Courier New" panose="02070309020205020404" pitchFamily="49" charset="0"/>
+                          <a:cs typeface="Courier New" panose="02070309020205020404" pitchFamily="49" charset="0"/>
+                        </a:rPr>
+                        <a:t>solution is not </a:t>
+                      </a:r>
+                      <a:r>
+                        <a:rPr lang="en-US" sz="1800" b="1" dirty="0">
+                          <a:solidFill>
+                            <a:schemeClr val="tx1"/>
+                          </a:solidFill>
+                          <a:latin typeface="Courier New" panose="02070309020205020404" pitchFamily="49" charset="0"/>
+                          <a:cs typeface="Courier New" panose="02070309020205020404" pitchFamily="49" charset="0"/>
+                        </a:rPr>
+                        <a:t>None:</a:t>
                       </a:r>
                     </a:p>
                     <a:p>

</xml_diff>